<commit_message>
Refresh generated sample documents
</commit_message>
<xml_diff>
--- a/documentos/marketing/plan-campana-dia-madre.pptx
+++ b/documentos/marketing/plan-campana-dia-madre.pptx
@@ -3107,7 +3107,7 @@
           <a:lstStyle/>
           <a:p>
             <a:r>
-              <a:t>Campaña Día de la Madre 2026 (ejemplo)</a:t>
+              <a:t>Campaña Día de la Madre 2026</a:t>
             </a:r>
           </a:p>
         </p:txBody>
@@ -3128,7 +3128,7 @@
           <a:lstStyle/>
           <a:p>
             <a:r>
-              <a:t>Ponqué Ponqué Calarcá — plan de marketing ficticio</a:t>
+              <a:t>Ponqué Ponqué Calarcá — plan de marketing</a:t>
             </a:r>
           </a:p>
         </p:txBody>
@@ -3188,7 +3188,7 @@
           <a:lstStyle/>
           <a:p>
             <a:r>
-              <a:t>Aumentar en 20% los pedidos de la semana del Día de la Madre frente al mes anterior (meta ficticia de ejemplo).</a:t>
+              <a:t>Aumentar en 20% los pedidos de la semana del Día de la Madre frente al mes anterior.</a:t>
             </a:r>
           </a:p>
         </p:txBody>
@@ -3318,7 +3318,7 @@
           <a:lstStyle/>
           <a:p>
             <a:r>
-              <a:t>Presupuesto: $1.500.000 COP (ficticio)</a:t>
+              <a:t>Presupuesto: $1.500.000 COP</a:t>
             </a:r>
           </a:p>
           <a:p>

</xml_diff>